<commit_message>
refactor: simplify slide texts, remove complex equations, make methodology a visual 4-step pipeline, and set references as slide 12 final slide
</commit_message>
<xml_diff>
--- a/SparsioQ_Final_Project_Review_Presentation.pptx
+++ b/SparsioQ_Final_Project_Review_Presentation.pptx
@@ -17,7 +17,6 @@
     <p:sldId id="265" r:id="rId16"/>
     <p:sldId id="266" r:id="rId17"/>
     <p:sldId id="267" r:id="rId18"/>
-    <p:sldId id="268" r:id="rId19"/>
   </p:sldIdLst>
   <p:sldSz cx="12191695" cy="6858000" type="screen4x3"/>
   <p:notesSz cx="6858000" cy="9144000"/>
@@ -3534,7 +3533,7 @@
           <a:p>
             <a:pPr>
               <a:spcAft>
-                <a:spcPts val="1200"/>
+                <a:spcPts val="1400"/>
               </a:spcAft>
               <a:defRPr sz="1500">
                 <a:solidFill>
@@ -3544,13 +3543,13 @@
               </a:defRPr>
             </a:pPr>
             <a:r>
-              <a:t>•  Live Market API Rate Limiting: Yahoo Finance throttled simultaneous bulk calls; solved via 60s TTL caching (@st.cache_data) with robust empirical fallback dictionaries.</a:t>
+              <a:t>•  Live Market Throttling: Yahoo Finance blocked rapid requests; solved using 60-second caching with verified fallback data.</a:t>
             </a:r>
           </a:p>
           <a:p>
             <a:pPr>
               <a:spcAft>
-                <a:spcPts val="1200"/>
+                <a:spcPts val="1400"/>
               </a:spcAft>
               <a:defRPr sz="1500">
                 <a:solidFill>
@@ -3560,13 +3559,13 @@
               </a:defRPr>
             </a:pPr>
             <a:r>
-              <a:t>•  Session State Bounds: StreamlitValueBelowMinError occurred when user balance reached ₹0; resolved by clamping min_value=0.0 and safely bounding all numeric inputs.</a:t>
+              <a:t>•  Session Balance Bounds: App crashed when balance reached ₹0; fixed by safely bounding minimum values and input limits.</a:t>
             </a:r>
           </a:p>
           <a:p>
             <a:pPr>
               <a:spcAft>
-                <a:spcPts val="1200"/>
+                <a:spcPts val="1400"/>
               </a:spcAft>
               <a:defRPr sz="1500">
                 <a:solidFill>
@@ -3576,13 +3575,13 @@
               </a:defRPr>
             </a:pPr>
             <a:r>
-              <a:t>•  Windows Terminal Encoding Glitches: cp1252 codec corrupted rupee symbols (₹) and emojis; solved by enforcing strict UTF-8 stream writers across the repository.</a:t>
+              <a:t>•  Windows Character Encoding: Fixed rupee symbols (₹) and emojis by enforcing strict UTF-8 standards across the codebase.</a:t>
             </a:r>
           </a:p>
           <a:p>
             <a:pPr>
               <a:spcAft>
-                <a:spcPts val="1200"/>
+                <a:spcPts val="1400"/>
               </a:spcAft>
               <a:defRPr sz="1500">
                 <a:solidFill>
@@ -3592,13 +3591,13 @@
               </a:defRPr>
             </a:pPr>
             <a:r>
-              <a:t>•  Quantum Circuit Simulation Overhead: Statevector exponential memory scaling O(2^n); resolved via 2-qubit Hilbert subspace projection in Qiskit Aer.</a:t>
+              <a:t>•  Future Work – Direct Broker Execution: Connect with Zerodha Kite Connect and Angel One APIs for automated stock execution.</a:t>
             </a:r>
           </a:p>
           <a:p>
             <a:pPr>
               <a:spcAft>
-                <a:spcPts val="1200"/>
+                <a:spcPts val="1400"/>
               </a:spcAft>
               <a:defRPr sz="1500">
                 <a:solidFill>
@@ -3608,13 +3607,13 @@
               </a:defRPr>
             </a:pPr>
             <a:r>
-              <a:t>•  Future Work – Real Broker API Routing: Integrate Zerodha Kite Connect and Angel One SmartAPI for automated live exchange order execution.</a:t>
+              <a:t>•  Future Work – Real Quantum Hardware: Run quantum option pricing circuits on real 156-qubit IBM Quantum Heron hardware.</a:t>
             </a:r>
           </a:p>
           <a:p>
             <a:pPr>
               <a:spcAft>
-                <a:spcPts val="1200"/>
+                <a:spcPts val="1400"/>
               </a:spcAft>
               <a:defRPr sz="1500">
                 <a:solidFill>
@@ -3624,7 +3623,7 @@
               </a:defRPr>
             </a:pPr>
             <a:r>
-              <a:t>•  Future Work – IBM Quantum Hardware: Deploy QAE circuits to 156-qubit IBM Quantum Heron processors, and expand asset universe into Sovereign Gold Bonds &amp; REITs.</a:t>
+              <a:t>•  Future Work – Multi-Asset Expansion: Expand portfolio optimization to include Sovereign Gold Bonds (SGB) and Real Estate REITs.</a:t>
             </a:r>
           </a:p>
         </p:txBody>
@@ -3810,7 +3809,7 @@
           <a:p>
             <a:pPr>
               <a:spcAft>
-                <a:spcPts val="1200"/>
+                <a:spcPts val="1400"/>
               </a:spcAft>
               <a:defRPr sz="1500">
                 <a:solidFill>
@@ -3820,13 +3819,13 @@
               </a:defRPr>
             </a:pPr>
             <a:r>
-              <a:t>•  Mathematical Rigor: Successfully implemented all 24MAT204 theoretical pillars: L1 convex optimization, Hidden Markov Models, 3D Tensor HoSVD, and Quantum QAE.</a:t>
+              <a:t>•  Mathematical Foundation: Successfully applied optimization, probability, and quantum concepts to solve real-world wealth problems.</a:t>
             </a:r>
           </a:p>
           <a:p>
             <a:pPr>
               <a:spcAft>
-                <a:spcPts val="1200"/>
+                <a:spcPts val="1400"/>
               </a:spcAft>
               <a:defRPr sz="1500">
                 <a:solidFill>
@@ -3836,13 +3835,13 @@
               </a:defRPr>
             </a:pPr>
             <a:r>
-              <a:t>•  Friction Elimination: Proved empirical 43.8% transaction fee reduction via L1 sparsity while maintaining an optimal portfolio Sharpe ratio of 1.58.</a:t>
+              <a:t>•  Proven Fee Savings: Confirmed that focusing on 4 core stocks cuts transaction fees by 43.8% while maintaining strong returns.</a:t>
             </a:r>
           </a:p>
           <a:p>
             <a:pPr>
               <a:spcAft>
-                <a:spcPts val="1200"/>
+                <a:spcPts val="1400"/>
               </a:spcAft>
               <a:defRPr sz="1500">
                 <a:solidFill>
@@ -3852,13 +3851,13 @@
               </a:defRPr>
             </a:pPr>
             <a:r>
-              <a:t>•  Software Engineering Excellence: Delivered a fully functional, zero-hallucination cloud application on Streamlit with live NSE streaming and 1-click UPI payments.</a:t>
+              <a:t>•  Working Production Software: Built a clean, fully functional cloud platform running on live National Stock Exchange market feeds.</a:t>
             </a:r>
           </a:p>
           <a:p>
             <a:pPr>
               <a:spcAft>
-                <a:spcPts val="1200"/>
+                <a:spcPts val="1400"/>
               </a:spcAft>
               <a:defRPr sz="1500">
                 <a:solidFill>
@@ -3868,13 +3867,13 @@
               </a:defRPr>
             </a:pPr>
             <a:r>
-              <a:t>•  Societal Democratization: Bridged the gap between high-level institutional mathematics and everyday retail investors, enabling balanced blue-chip investing starting at ₹100.</a:t>
+              <a:t>•  Empowering Retail Savers: Enabled everyday beginners to invest small amounts starting at ₹100 into safe, diversified blue-chip leaders.</a:t>
             </a:r>
           </a:p>
           <a:p>
             <a:pPr>
               <a:spcAft>
-                <a:spcPts val="1200"/>
+                <a:spcPts val="1400"/>
               </a:spcAft>
               <a:defRPr sz="1500">
                 <a:solidFill>
@@ -3884,7 +3883,7 @@
               </a:defRPr>
             </a:pPr>
             <a:r>
-              <a:t>•  Regulatory Compliance: Integrated SEBI risk disclosures and RBI Account Aggregator 2FA protocols to guarantee investor safety and capital protection.</a:t>
+              <a:t>•  Regulatory Compliance: Incorporated SEBI risk disclosures and RBI Account Aggregator protocols to ensure investor safety.</a:t>
             </a:r>
           </a:p>
         </p:txBody>
@@ -4070,7 +4069,7 @@
           <a:p>
             <a:pPr>
               <a:spcAft>
-                <a:spcPts val="1200"/>
+                <a:spcPts val="1400"/>
               </a:spcAft>
               <a:defRPr sz="1500">
                 <a:solidFill>
@@ -4080,13 +4079,13 @@
               </a:defRPr>
             </a:pPr>
             <a:r>
-              <a:t>•  1. Markowitz, H. (1952): 'Portfolio Selection.' The Journal of Finance, 7(1), 77–91. (Foundational Mean-Variance Optimization).</a:t>
+              <a:t>•  1. Markowitz, H. (1952): 'Portfolio Selection.' The Journal of Finance, 7(1), 77–91. (Foundational Portfolio Theory).</a:t>
             </a:r>
           </a:p>
           <a:p>
             <a:pPr>
               <a:spcAft>
-                <a:spcPts val="1200"/>
+                <a:spcPts val="1400"/>
               </a:spcAft>
               <a:defRPr sz="1500">
                 <a:solidFill>
@@ -4096,13 +4095,13 @@
               </a:defRPr>
             </a:pPr>
             <a:r>
-              <a:t>•  2. Tibshirani, R. (1996): 'Regression shrinkage and selection via the Lasso.' Journal of the Royal Statistical Society, 58(1), 267–288. (L1 Norm Sparsity).</a:t>
+              <a:t>•  2. Tibshirani, R. (1996): 'Regression shrinkage and selection via the Lasso.' Journal of the Royal Statistical Society. (L1 Regularization).</a:t>
             </a:r>
           </a:p>
           <a:p>
             <a:pPr>
               <a:spcAft>
-                <a:spcPts val="1200"/>
+                <a:spcPts val="1400"/>
               </a:spcAft>
               <a:defRPr sz="1500">
                 <a:solidFill>
@@ -4112,13 +4111,13 @@
               </a:defRPr>
             </a:pPr>
             <a:r>
-              <a:t>•  3. Boyd, S., &amp; Vandenberghe, L. (2004): Convex Optimization. Cambridge University Press. (CVXOPT KKT Solvers).</a:t>
+              <a:t>•  3. Boyd, S., &amp; Vandenberghe, L. (2004): Convex Optimization. Cambridge University Press. (CVXOPT Solvers).</a:t>
             </a:r>
           </a:p>
           <a:p>
             <a:pPr>
               <a:spcAft>
-                <a:spcPts val="1200"/>
+                <a:spcPts val="1400"/>
               </a:spcAft>
               <a:defRPr sz="1500">
                 <a:solidFill>
@@ -4128,13 +4127,13 @@
               </a:defRPr>
             </a:pPr>
             <a:r>
-              <a:t>•  4. Rabiner, L. R. (1989): 'A tutorial on Hidden Markov Models and selected applications.' Proceedings of the IEEE, 77(2), 257–286. (Baum-Welch &amp; Viterbi).</a:t>
+              <a:t>•  4. Rabiner, L. R. (1989): 'A tutorial on Hidden Markov Models.' Proceedings of the IEEE, 77(2), 257–286. (Market Regimes).</a:t>
             </a:r>
           </a:p>
           <a:p>
             <a:pPr>
               <a:spcAft>
-                <a:spcPts val="1200"/>
+                <a:spcPts val="1400"/>
               </a:spcAft>
               <a:defRPr sz="1500">
                 <a:solidFill>
@@ -4144,13 +4143,13 @@
               </a:defRPr>
             </a:pPr>
             <a:r>
-              <a:t>•  5. Tucker, L. R. (1966): 'Some mathematical notes on three-mode factor analysis.' Psychometrika, 31(3), 279–311. (Higher-Order SVD &amp; Multilinear Tensors).</a:t>
+              <a:t>•  5. Tucker, L. R. (1966): 'Some mathematical notes on three-mode factor analysis.' Psychometrika. (Multilinear Tensors).</a:t>
             </a:r>
           </a:p>
           <a:p>
             <a:pPr>
               <a:spcAft>
-                <a:spcPts val="1200"/>
+                <a:spcPts val="1400"/>
               </a:spcAft>
               <a:defRPr sz="1500">
                 <a:solidFill>
@@ -4160,13 +4159,13 @@
               </a:defRPr>
             </a:pPr>
             <a:r>
-              <a:t>•  6. Brassard, G., Hoyer, P., Mosca, M., &amp; Tapp, A. (2002): 'Quantum Amplitude Amplification and Estimation.' Contemporary Mathematics, 305, 53–74. (Quadratic Speedup O(1/ε)).</a:t>
+              <a:t>•  6. Brassard, G., et al. (2002): 'Quantum Amplitude Amplification and Estimation.' Contemporary Mathematics. (Quantum Speedup).</a:t>
             </a:r>
           </a:p>
           <a:p>
             <a:pPr>
               <a:spcAft>
-                <a:spcPts val="1200"/>
+                <a:spcPts val="1400"/>
               </a:spcAft>
               <a:defRPr sz="1500">
                 <a:solidFill>
@@ -4176,13 +4175,13 @@
               </a:defRPr>
             </a:pPr>
             <a:r>
-              <a:t>•  7. Black, F., &amp; Scholes, M. (1973): 'The Pricing of Options and Corporate Liabilities.' Journal of Political Economy, 81(3), 637–654.</a:t>
+              <a:t>•  7. Black, F., &amp; Scholes, M. (1973): 'The Pricing of Options and Corporate Liabilities.' Journal of Political Economy.</a:t>
             </a:r>
           </a:p>
           <a:p>
             <a:pPr>
               <a:spcAft>
-                <a:spcPts val="1200"/>
+                <a:spcPts val="1400"/>
               </a:spcAft>
               <a:defRPr sz="1500">
                 <a:solidFill>
@@ -4192,315 +4191,7 @@
               </a:defRPr>
             </a:pPr>
             <a:r>
-              <a:t>•  8. SEBI (2024): 'Study on Analysis of Profit and Loss of Individual Traders in Equity Market and Algorithmic Disclosures.' Securities and Exchange Board of India.</a:t>
-            </a:r>
-          </a:p>
-        </p:txBody>
-      </p:sp>
-    </p:spTree>
-  </p:cSld>
-  <p:clrMapOvr>
-    <a:masterClrMapping/>
-  </p:clrMapOvr>
-</p:sld>
-</file>
-
-<file path=ppt/slides/slide13.xml><?xml version="1.0" encoding="utf-8"?>
-<p:sld xmlns:a="http://schemas.openxmlformats.org/drawingml/2006/main" xmlns:p="http://schemas.openxmlformats.org/presentationml/2006/main" xmlns:r="http://schemas.openxmlformats.org/officeDocument/2006/relationships">
-  <p:cSld>
-    <p:spTree>
-      <p:nvGrpSpPr>
-        <p:cNvPr id="1" name=""/>
-        <p:cNvGrpSpPr/>
-        <p:nvPr/>
-      </p:nvGrpSpPr>
-      <p:grpSpPr/>
-      <p:sp>
-        <p:nvSpPr>
-          <p:cNvPr id="2" name="Rectangle 1"/>
-          <p:cNvSpPr/>
-          <p:nvPr/>
-        </p:nvSpPr>
-        <p:spPr>
-          <a:xfrm>
-            <a:off x="0" y="0"/>
-            <a:ext cx="12191695" cy="6858000"/>
-          </a:xfrm>
-          <a:prstGeom prst="rect">
-            <a:avLst/>
-          </a:prstGeom>
-          <a:solidFill>
-            <a:srgbClr val="FFFFFF"/>
-          </a:solidFill>
-          <a:ln>
-            <a:noFill/>
-          </a:ln>
-        </p:spPr>
-        <p:style>
-          <a:lnRef idx="1">
-            <a:schemeClr val="accent1"/>
-          </a:lnRef>
-          <a:fillRef idx="3">
-            <a:schemeClr val="accent1"/>
-          </a:fillRef>
-          <a:effectRef idx="2">
-            <a:schemeClr val="accent1"/>
-          </a:effectRef>
-          <a:fontRef idx="minor">
-            <a:schemeClr val="lt1"/>
-          </a:fontRef>
-        </p:style>
-        <p:txBody>
-          <a:bodyPr rtlCol="0" anchor="ctr"/>
-          <a:lstStyle/>
-          <a:p>
-            <a:pPr algn="ctr"/>
-          </a:p>
-        </p:txBody>
-      </p:sp>
-      <p:pic>
-        <p:nvPicPr>
-          <p:cNvPr id="3" name="Picture 2" descr="amrita_logo_extracted.png"/>
-          <p:cNvPicPr>
-            <a:picLocks noChangeAspect="1"/>
-          </p:cNvPicPr>
-          <p:nvPr/>
-        </p:nvPicPr>
-        <p:blipFill>
-          <a:blip r:embed="rId2"/>
-          <a:stretch>
-            <a:fillRect/>
-          </a:stretch>
-        </p:blipFill>
-        <p:spPr>
-          <a:xfrm>
-            <a:off x="9326880" y="320040"/>
-            <a:ext cx="2377440" cy="713232"/>
-          </a:xfrm>
-          <a:prstGeom prst="rect">
-            <a:avLst/>
-          </a:prstGeom>
-        </p:spPr>
-      </p:pic>
-      <p:sp>
-        <p:nvSpPr>
-          <p:cNvPr id="4" name="TextBox 3"/>
-          <p:cNvSpPr txBox="1"/>
-          <p:nvPr/>
-        </p:nvSpPr>
-        <p:spPr>
-          <a:xfrm>
-            <a:off x="731520" y="411480"/>
-            <a:ext cx="8503920" cy="822960"/>
-          </a:xfrm>
-          <a:prstGeom prst="rect">
-            <a:avLst/>
-          </a:prstGeom>
-          <a:noFill/>
-        </p:spPr>
-        <p:txBody>
-          <a:bodyPr wrap="square">
-            <a:spAutoFit/>
-          </a:bodyPr>
-          <a:lstStyle/>
-          <a:p>
-            <a:pPr>
-              <a:defRPr sz="2500" b="1">
-                <a:solidFill>
-                  <a:srgbClr val="111111"/>
-                </a:solidFill>
-                <a:latin typeface="Times New Roman"/>
-              </a:defRPr>
-            </a:pPr>
-            <a:r>
-              <a:t>INDIVIDUAL VIVA VOCE DEFENSE GUIDE</a:t>
-            </a:r>
-          </a:p>
-        </p:txBody>
-      </p:sp>
-      <p:sp>
-        <p:nvSpPr>
-          <p:cNvPr id="5" name="TextBox 4"/>
-          <p:cNvSpPr txBox="1"/>
-          <p:nvPr/>
-        </p:nvSpPr>
-        <p:spPr>
-          <a:xfrm>
-            <a:off x="10789920" y="6263640"/>
-            <a:ext cx="822960" cy="365760"/>
-          </a:xfrm>
-          <a:prstGeom prst="rect">
-            <a:avLst/>
-          </a:prstGeom>
-          <a:noFill/>
-        </p:spPr>
-        <p:txBody>
-          <a:bodyPr wrap="none">
-            <a:spAutoFit/>
-          </a:bodyPr>
-          <a:lstStyle/>
-          <a:p>
-            <a:pPr>
-              <a:defRPr sz="1600" b="1">
-                <a:solidFill>
-                  <a:srgbClr val="646464"/>
-                </a:solidFill>
-                <a:latin typeface="Times New Roman"/>
-              </a:defRPr>
-            </a:pPr>
-            <a:r>
-              <a:t>12</a:t>
-            </a:r>
-          </a:p>
-        </p:txBody>
-      </p:sp>
-      <p:sp>
-        <p:nvSpPr>
-          <p:cNvPr id="6" name="TextBox 5"/>
-          <p:cNvSpPr txBox="1"/>
-          <p:nvPr/>
-        </p:nvSpPr>
-        <p:spPr>
-          <a:xfrm>
-            <a:off x="731520" y="1325880"/>
-            <a:ext cx="10698480" cy="4846320"/>
-          </a:xfrm>
-          <a:prstGeom prst="rect">
-            <a:avLst/>
-          </a:prstGeom>
-          <a:noFill/>
-        </p:spPr>
-        <p:txBody>
-          <a:bodyPr wrap="square">
-            <a:spAutoFit/>
-          </a:bodyPr>
-          <a:lstStyle/>
-          <a:p>
-            <a:pPr>
-              <a:spcAft>
-                <a:spcPts val="1200"/>
-              </a:spcAft>
-              <a:defRPr sz="1500">
-                <a:solidFill>
-                  <a:srgbClr val="222222"/>
-                </a:solidFill>
-                <a:latin typeface="Times New Roman"/>
-              </a:defRPr>
-            </a:pPr>
-            <a:r>
-              <a:t>•  Mhalsa Padmakumar (CB.AI.U4AIM25052) – System Architecture &amp; L1 Convex Optimization:</a:t>
-            </a:r>
-          </a:p>
-          <a:p>
-            <a:pPr>
-              <a:spcAft>
-                <a:spcPts val="1200"/>
-              </a:spcAft>
-              <a:defRPr sz="1500">
-                <a:solidFill>
-                  <a:srgbClr val="222222"/>
-                </a:solidFill>
-                <a:latin typeface="Times New Roman"/>
-              </a:defRPr>
-            </a:pPr>
-            <a:r>
-              <a:t>     ▶ Defense: L1 norm ||w||_1 has singular subdifferentials at w_i=0. KKT conditions force non-essential weights to exact zero, cutting turnover fees by 43.8%.</a:t>
-            </a:r>
-          </a:p>
-          <a:p>
-            <a:pPr>
-              <a:spcAft>
-                <a:spcPts val="1200"/>
-              </a:spcAft>
-              <a:defRPr sz="1500">
-                <a:solidFill>
-                  <a:srgbClr val="222222"/>
-                </a:solidFill>
-                <a:latin typeface="Times New Roman"/>
-              </a:defRPr>
-            </a:pPr>
-            <a:r>
-              <a:t>•  Shiza CKV (CB.AI.U4AIM25037) – Gaussian Hidden Markov Models (HMM) &amp; Regime Detection:</a:t>
-            </a:r>
-          </a:p>
-          <a:p>
-            <a:pPr>
-              <a:spcAft>
-                <a:spcPts val="1200"/>
-              </a:spcAft>
-              <a:defRPr sz="1500">
-                <a:solidFill>
-                  <a:srgbClr val="222222"/>
-                </a:solidFill>
-                <a:latin typeface="Times New Roman"/>
-              </a:defRPr>
-            </a:pPr>
-            <a:r>
-              <a:t>     ▶ Defense: 3-State HMM models Bull, Consolidation, and Bear regimes. Transition matrix A and emissions N(μ_k, σ_k^2) calibrated via Baum-Welch EM; decoded via Viterbi.</a:t>
-            </a:r>
-          </a:p>
-          <a:p>
-            <a:pPr>
-              <a:spcAft>
-                <a:spcPts val="1200"/>
-              </a:spcAft>
-              <a:defRPr sz="1500">
-                <a:solidFill>
-                  <a:srgbClr val="222222"/>
-                </a:solidFill>
-                <a:latin typeface="Times New Roman"/>
-              </a:defRPr>
-            </a:pPr>
-            <a:r>
-              <a:t>•  Anwaika Sanvi (CB.AI.U4AIM25044) – 3D Tensor HoSVD Multilinear Factor Analysis:</a:t>
-            </a:r>
-          </a:p>
-          <a:p>
-            <a:pPr>
-              <a:spcAft>
-                <a:spcPts val="1200"/>
-              </a:spcAft>
-              <a:defRPr sz="1500">
-                <a:solidFill>
-                  <a:srgbClr val="222222"/>
-                </a:solidFill>
-                <a:latin typeface="Times New Roman"/>
-              </a:defRPr>
-            </a:pPr>
-            <a:r>
-              <a:t>     ▶ Defense: 2D PCA flattens data and loses cross-mode correlations. Tucker HoSVD decomposes 3D tensor X into core G and factor matrices U_1, U_2, U_3 across macro modes.</a:t>
-            </a:r>
-          </a:p>
-          <a:p>
-            <a:pPr>
-              <a:spcAft>
-                <a:spcPts val="1200"/>
-              </a:spcAft>
-              <a:defRPr sz="1500">
-                <a:solidFill>
-                  <a:srgbClr val="222222"/>
-                </a:solidFill>
-                <a:latin typeface="Times New Roman"/>
-              </a:defRPr>
-            </a:pPr>
-            <a:r>
-              <a:t>•  Joshika (CB.AI.U4AIM25014) – MDP RL Trade Slicer &amp; Quantum QAE Derivative Pricing:</a:t>
-            </a:r>
-          </a:p>
-          <a:p>
-            <a:pPr>
-              <a:spcAft>
-                <a:spcPts val="1200"/>
-              </a:spcAft>
-              <a:defRPr sz="1500">
-                <a:solidFill>
-                  <a:srgbClr val="222222"/>
-                </a:solidFill>
-                <a:latin typeface="Times New Roman"/>
-              </a:defRPr>
-            </a:pPr>
-            <a:r>
-              <a:t>     ▶ Defense: Classical Monte Carlo error scales as O(1/√M). QAE applies Grover iterations Q in a 2-qubit Hilbert subspace, scaling error as O(1/M) with quadratic speedup.</a:t>
+              <a:t>•  8. SEBI (2024): 'Study on Profit and Loss of Individual Traders in Equity Market.' Securities and Exchange Board of India.</a:t>
             </a:r>
           </a:p>
         </p:txBody>
@@ -4686,7 +4377,7 @@
           <a:p>
             <a:pPr>
               <a:spcAft>
-                <a:spcPts val="1200"/>
+                <a:spcPts val="1400"/>
               </a:spcAft>
               <a:defRPr sz="1500">
                 <a:solidFill>
@@ -4696,13 +4387,13 @@
               </a:defRPr>
             </a:pPr>
             <a:r>
-              <a:t>•  The Retail Wealth Barrier: High individual stock prices (MRF: ₹1.4L, TCS: ₹4.1K, Reliance: ₹1.3K) lock small retail savers out of balanced blue-chip portfolios.</a:t>
+              <a:t>•  The Retail Wealth Barrier: High individual stock prices (like MRF, TCS, and Reliance) prevent small retail savers from building safe, diversified portfolios.</a:t>
             </a:r>
           </a:p>
           <a:p>
             <a:pPr>
               <a:spcAft>
-                <a:spcPts val="1200"/>
+                <a:spcPts val="1400"/>
               </a:spcAft>
               <a:defRPr sz="1500">
                 <a:solidFill>
@@ -4712,13 +4403,13 @@
               </a:defRPr>
             </a:pPr>
             <a:r>
-              <a:t>•  Severe Retail Losses: SEBI (2024) reports that 93% of Indian retail traders lose money due to forced speculation in penny stocks and high-risk derivatives.</a:t>
+              <a:t>•  Severe Retail Losses: Studies show that over 90% of retail traders lose money by gambling on risky derivatives and unverified tips.</a:t>
             </a:r>
           </a:p>
           <a:p>
             <a:pPr>
               <a:spcAft>
-                <a:spcPts val="1200"/>
+                <a:spcPts val="1400"/>
               </a:spcAft>
               <a:defRPr sz="1500">
                 <a:solidFill>
@@ -4728,13 +4419,13 @@
               </a:defRPr>
             </a:pPr>
             <a:r>
-              <a:t>•  The Institutional Quant Gap: Advanced mathematical tools (L1 optimization, HMM regimes, tensor factorizations) have historically been exclusive to hedge funds.</a:t>
+              <a:t>•  The Quant Gap: Advanced portfolio optimization and risk detection tools have traditionally been restricted to wealthy hedge funds and institutions.</a:t>
             </a:r>
           </a:p>
           <a:p>
             <a:pPr>
               <a:spcAft>
-                <a:spcPts val="1200"/>
+                <a:spcPts val="1400"/>
               </a:spcAft>
               <a:defRPr sz="1500">
                 <a:solidFill>
@@ -4744,13 +4435,13 @@
               </a:defRPr>
             </a:pPr>
             <a:r>
-              <a:t>•  The SparsioQ Solution: An algorithmic wealth platform democratizing micro-investing from ₹100 using dynamic fractional shares (0.0001 precision).</a:t>
+              <a:t>•  The SparsioQ Solution: A simple platform that brings institutional math to everyday people, enabling micro-investing starting from just ₹100.</a:t>
             </a:r>
           </a:p>
           <a:p>
             <a:pPr>
               <a:spcAft>
-                <a:spcPts val="1200"/>
+                <a:spcPts val="1400"/>
               </a:spcAft>
               <a:defRPr sz="1500">
                 <a:solidFill>
@@ -4760,7 +4451,7 @@
               </a:defRPr>
             </a:pPr>
             <a:r>
-              <a:t>•  Dual-Mode Experience: Zero-Knowledge Auto-Pilot for everyday beginners and Quant Pro Mode for academic researchers and quants.</a:t>
+              <a:t>•  Dual-Mode Experience: Includes Auto-Pilot Mode for beginners with 1-click UPI payments, and Quant Pro Mode for researchers and finance evaluators.</a:t>
             </a:r>
           </a:p>
         </p:txBody>
@@ -4946,7 +4637,7 @@
           <a:p>
             <a:pPr>
               <a:spcAft>
-                <a:spcPts val="1200"/>
+                <a:spcPts val="1400"/>
               </a:spcAft>
               <a:defRPr sz="1500">
                 <a:solidFill>
@@ -4956,13 +4647,13 @@
               </a:defRPr>
             </a:pPr>
             <a:r>
-              <a:t>•  Discrete Capital Allocation Barrier: Standard exchanges mandate integer lot sizes, creating cash drag and preventing exact rupee budgeting under ₹10,000.</a:t>
+              <a:t>•  Discrete Share Barrier: Traditional stock brokers require buying full shares, leaving unspent cash sitting idle without earning returns.</a:t>
             </a:r>
           </a:p>
           <a:p>
             <a:pPr>
               <a:spcAft>
-                <a:spcPts val="1200"/>
+                <a:spcPts val="1400"/>
               </a:spcAft>
               <a:defRPr sz="1500">
                 <a:solidFill>
@@ -4972,13 +4663,13 @@
               </a:defRPr>
             </a:pPr>
             <a:r>
-              <a:t>•  Turnover &amp; Friction Cost Drag: Classical Markowitz quadratic optimization creates dense 30–50 stock portfolios, where rebalancing fees eat &gt;40% of returns.</a:t>
+              <a:t>•  High Transaction Fee Drag: Traditional portfolio models spread money across 30 to 50 small stocks, where brokerage fees eat away over 40% of profits.</a:t>
             </a:r>
           </a:p>
           <a:p>
             <a:pPr>
               <a:spcAft>
-                <a:spcPts val="1200"/>
+                <a:spcPts val="1400"/>
               </a:spcAft>
               <a:defRPr sz="1500">
                 <a:solidFill>
@@ -4988,13 +4679,13 @@
               </a:defRPr>
             </a:pPr>
             <a:r>
-              <a:t>•  Non-Stationary Regime Shifts: Static models fail during black-swan liquidity shocks because asset return distributions shift between Bull and Bear regimes.</a:t>
+              <a:t>•  Unpredictable Market Crashes: Standard financial models assume markets are steady, failing to protect investors when sudden crashes occur.</a:t>
             </a:r>
           </a:p>
           <a:p>
             <a:pPr>
               <a:spcAft>
-                <a:spcPts val="1200"/>
+                <a:spcPts val="1400"/>
               </a:spcAft>
               <a:defRPr sz="1500">
                 <a:solidFill>
@@ -5004,13 +4695,13 @@
               </a:defRPr>
             </a:pPr>
             <a:r>
-              <a:t>•  Derivative Pricing Computational Latency: Classical Monte Carlo option pricing converges slowly at O(1/√M), causing latency in high-frequency portfolio hedging.</a:t>
+              <a:t>•  Slow Option Pricing Speed: Traditional computer simulations are too slow for real-time pricing and risk hedging during fast market movements.</a:t>
             </a:r>
           </a:p>
           <a:p>
             <a:pPr>
               <a:spcAft>
-                <a:spcPts val="1200"/>
+                <a:spcPts val="1400"/>
               </a:spcAft>
               <a:defRPr sz="1500">
                 <a:solidFill>
@@ -5020,7 +4711,7 @@
               </a:defRPr>
             </a:pPr>
             <a:r>
-              <a:t>•  Core Engineering Objective: To engineer a real-time, L1-sparse, regime-resilient platform with quantum derivative acceleration starting at ₹100.</a:t>
+              <a:t>•  Project Goal: To build a clean, real-time web platform that solves these issues using fractional shares, smart portfolio math, and quantum speed.</a:t>
             </a:r>
           </a:p>
         </p:txBody>
@@ -5206,7 +4897,7 @@
           <a:p>
             <a:pPr>
               <a:spcAft>
-                <a:spcPts val="1200"/>
+                <a:spcPts val="1400"/>
               </a:spcAft>
               <a:defRPr sz="1500">
                 <a:solidFill>
@@ -5216,13 +4907,13 @@
               </a:defRPr>
             </a:pPr>
             <a:r>
-              <a:t>•  1. Micro-Investment Fractional Slicing: Parameterize any rupee input (₹100 to ₹10L) into fractional shares down to 0.0001 precision with 1-click execution.</a:t>
+              <a:t>•  1. Micro-Investment Engine: Split any investment amount (from ₹100 up to ₹10 Lakhs) into exact fractional shares with zero wasted money.</a:t>
             </a:r>
           </a:p>
           <a:p>
             <a:pPr>
               <a:spcAft>
-                <a:spcPts val="1200"/>
+                <a:spcPts val="1400"/>
               </a:spcAft>
               <a:defRPr sz="1500">
                 <a:solidFill>
@@ -5232,13 +4923,13 @@
               </a:defRPr>
             </a:pPr>
             <a:r>
-              <a:t>•  2. L1 Sparse Markowitz Optimization: Formulate an L1-regularized convex portfolio via CVXOPT to cut transaction friction and turnover fees by &gt;40%.</a:t>
+              <a:t>•  2. Sparse Portfolio Optimization: Use L1-Regularized Markowitz Optimization to select the top 4 core stocks, cutting transaction fees by over 40%.</a:t>
             </a:r>
           </a:p>
           <a:p>
             <a:pPr>
               <a:spcAft>
-                <a:spcPts val="1200"/>
+                <a:spcPts val="1400"/>
               </a:spcAft>
               <a:defRPr sz="1500">
                 <a:solidFill>
@@ -5248,13 +4939,13 @@
               </a:defRPr>
             </a:pPr>
             <a:r>
-              <a:t>•  3. Stochastic Regime &amp; Tensor Analysis: Implement a 3-State Gaussian HMM (Baum-Welch/Viterbi) and 3D Tensor Tucker HoSVD to isolate systematic macro risk.</a:t>
+              <a:t>•  3. Market Regime Detection: Use Gaussian Hidden Markov Models to detect whether the market is in a safe Bull cycle or a dangerous Bear cycle.</a:t>
             </a:r>
           </a:p>
           <a:p>
             <a:pPr>
               <a:spcAft>
-                <a:spcPts val="1200"/>
+                <a:spcPts val="1400"/>
               </a:spcAft>
               <a:defRPr sz="1500">
                 <a:solidFill>
@@ -5264,13 +4955,13 @@
               </a:defRPr>
             </a:pPr>
             <a:r>
-              <a:t>•  4. Quantum Derivative Acceleration: Construct Qiskit Quantum Amplitude Estimation (QAE) circuits providing quadratic speedup O(1/ε) over Monte Carlo.</a:t>
+              <a:t>•  4. Quantum Option Pricing: Implement Quantum Amplitude Estimation using Qiskit to calculate derivative prices with quadratic speedup.</a:t>
             </a:r>
           </a:p>
           <a:p>
             <a:pPr>
               <a:spcAft>
-                <a:spcPts val="1200"/>
+                <a:spcPts val="1400"/>
               </a:spcAft>
               <a:defRPr sz="1500">
                 <a:solidFill>
@@ -5280,7 +4971,7 @@
               </a:defRPr>
             </a:pPr>
             <a:r>
-              <a:t>•  5. End-to-End Cloud Deployment: Build a 100% live cloud application with real-time NSE streaming, NPCI UPI intent links, and liquid portfolio tracking.</a:t>
+              <a:t>•  5. Live Real-Time Platform: Deploy an end-to-end cloud platform streaming real National Stock Exchange (NSE) prices with instant UPI payments.</a:t>
             </a:r>
           </a:p>
         </p:txBody>
@@ -5466,7 +5157,7 @@
           <a:p>
             <a:pPr>
               <a:spcAft>
-                <a:spcPts val="1200"/>
+                <a:spcPts val="1400"/>
               </a:spcAft>
               <a:defRPr sz="1500">
                 <a:solidFill>
@@ -5476,13 +5167,13 @@
               </a:defRPr>
             </a:pPr>
             <a:r>
-              <a:t>•  Minimum Capital Entry: Traditional brokers require ₹5,000–₹50,000+ vs. SparsioQ requires exact ₹100 with zero cash drag.</a:t>
+              <a:t>•  Minimum Investment: Traditional brokers require ₹5,000 to ₹50,000+ vs. SparsioQ works with any amount starting at just ₹100.</a:t>
             </a:r>
           </a:p>
           <a:p>
             <a:pPr>
               <a:spcAft>
-                <a:spcPts val="1200"/>
+                <a:spcPts val="1400"/>
               </a:spcAft>
               <a:defRPr sz="1500">
                 <a:solidFill>
@@ -5492,13 +5183,13 @@
               </a:defRPr>
             </a:pPr>
             <a:r>
-              <a:t>•  Share Allocation Units: Existing platforms allow only integer shares vs. SparsioQ computes dynamic 0.0001 fractional units.</a:t>
+              <a:t>•  Share Buying Units: Existing brokers only allow whole integer shares vs. SparsioQ calculates fractional shares down to 4 decimal places.</a:t>
             </a:r>
           </a:p>
           <a:p>
             <a:pPr>
               <a:spcAft>
-                <a:spcPts val="1200"/>
+                <a:spcPts val="1400"/>
               </a:spcAft>
               <a:defRPr sz="1500">
                 <a:solidFill>
@@ -5508,13 +5199,13 @@
               </a:defRPr>
             </a:pPr>
             <a:r>
-              <a:t>•  Portfolio Architecture: Traditional models yield dense 30–50 asset vectors vs. SparsioQ enforces L1 sparsity (4 core assets, 43.8% fee savings).</a:t>
+              <a:t>•  Portfolio Simplicity: Traditional models buy 30 to 50 stocks with high fees vs. SparsioQ focuses on 4 core leaders, saving 43.8% in fees.</a:t>
             </a:r>
           </a:p>
           <a:p>
             <a:pPr>
               <a:spcAft>
-                <a:spcPts val="1200"/>
+                <a:spcPts val="1400"/>
               </a:spcAft>
               <a:defRPr sz="1500">
                 <a:solidFill>
@@ -5524,13 +5215,13 @@
               </a:defRPr>
             </a:pPr>
             <a:r>
-              <a:t>•  Market Regime Adaptation: Existing robo-advisors assume static markets vs. SparsioQ incorporates 3-State Gaussian HMM regime shift detection.</a:t>
+              <a:t>•  Market Crash Awareness: Existing robo-advisors assume steady markets vs. SparsioQ automatically adapts to Bull and Bear market cycles.</a:t>
             </a:r>
           </a:p>
           <a:p>
             <a:pPr>
               <a:spcAft>
-                <a:spcPts val="1200"/>
+                <a:spcPts val="1400"/>
               </a:spcAft>
               <a:defRPr sz="1500">
                 <a:solidFill>
@@ -5540,13 +5231,13 @@
               </a:defRPr>
             </a:pPr>
             <a:r>
-              <a:t>•  Derivative Pricing: Standard platforms use classical Black-Scholes/Monte Carlo vs. SparsioQ implements Qiskit Quantum QAE with quadratic speedup.</a:t>
+              <a:t>•  Option Pricing: Standard tools use slow classical simulations vs. SparsioQ uses quantum circuits for quadratic computing speed.</a:t>
             </a:r>
           </a:p>
           <a:p>
             <a:pPr>
               <a:spcAft>
-                <a:spcPts val="1200"/>
+                <a:spcPts val="1400"/>
               </a:spcAft>
               <a:defRPr sz="1500">
                 <a:solidFill>
@@ -5556,7 +5247,7 @@
               </a:defRPr>
             </a:pPr>
             <a:r>
-              <a:t>•  User Accessibility: Existing tools require deep financial knowledge vs. SparsioQ provides 1-Click Auto-Pilot with live UPI app integration.</a:t>
+              <a:t>•  Ease of Use: Other tools require finance expertise vs. SparsioQ offers 1-Click Auto-Pilot with Google Pay, PhonePe, and Paytm integration.</a:t>
             </a:r>
           </a:p>
         </p:txBody>
@@ -5720,14 +5411,95 @@
       </p:sp>
       <p:sp>
         <p:nvSpPr>
-          <p:cNvPr id="6" name="TextBox 5"/>
+          <p:cNvPr id="6" name="Rounded Rectangle 5"/>
+          <p:cNvSpPr/>
+          <p:nvPr/>
+        </p:nvSpPr>
+        <p:spPr>
+          <a:xfrm>
+            <a:off x="731520" y="1371600"/>
+            <a:ext cx="2523744" cy="4663440"/>
+          </a:xfrm>
+          <a:prstGeom prst="roundRect">
+            <a:avLst/>
+          </a:prstGeom>
+          <a:solidFill>
+            <a:srgbClr val="EEF2FF"/>
+          </a:solidFill>
+          <a:ln w="25400">
+            <a:solidFill>
+              <a:srgbClr val="4F46E5"/>
+            </a:solidFill>
+          </a:ln>
+        </p:spPr>
+        <p:style>
+          <a:lnRef idx="1">
+            <a:schemeClr val="accent1"/>
+          </a:lnRef>
+          <a:fillRef idx="3">
+            <a:schemeClr val="accent1"/>
+          </a:fillRef>
+          <a:effectRef idx="2">
+            <a:schemeClr val="accent1"/>
+          </a:effectRef>
+          <a:fontRef idx="minor">
+            <a:schemeClr val="lt1"/>
+          </a:fontRef>
+        </p:style>
+        <p:txBody>
+          <a:bodyPr rtlCol="0" anchor="ctr"/>
+          <a:lstStyle/>
+          <a:p>
+            <a:pPr algn="ctr"/>
+          </a:p>
+        </p:txBody>
+      </p:sp>
+      <p:sp>
+        <p:nvSpPr>
+          <p:cNvPr id="7" name="TextBox 6"/>
           <p:cNvSpPr txBox="1"/>
           <p:nvPr/>
         </p:nvSpPr>
         <p:spPr>
           <a:xfrm>
-            <a:off x="731520" y="1325880"/>
-            <a:ext cx="10698480" cy="4846320"/>
+            <a:off x="868680" y="1508760"/>
+            <a:ext cx="2249424" cy="365760"/>
+          </a:xfrm>
+          <a:prstGeom prst="rect">
+            <a:avLst/>
+          </a:prstGeom>
+          <a:noFill/>
+        </p:spPr>
+        <p:txBody>
+          <a:bodyPr wrap="none">
+            <a:spAutoFit/>
+          </a:bodyPr>
+          <a:lstStyle/>
+          <a:p>
+            <a:pPr>
+              <a:defRPr sz="1200" b="1">
+                <a:solidFill>
+                  <a:srgbClr val="4F46E5"/>
+                </a:solidFill>
+                <a:latin typeface="Times New Roman"/>
+              </a:defRPr>
+            </a:pPr>
+            <a:r>
+              <a:t>STEP 1: LIVE INGESTION</a:t>
+            </a:r>
+          </a:p>
+        </p:txBody>
+      </p:sp>
+      <p:sp>
+        <p:nvSpPr>
+          <p:cNvPr id="8" name="TextBox 7"/>
+          <p:cNvSpPr txBox="1"/>
+          <p:nvPr/>
+        </p:nvSpPr>
+        <p:spPr>
+          <a:xfrm>
+            <a:off x="868680" y="1874520"/>
+            <a:ext cx="2249424" cy="548640"/>
           </a:xfrm>
           <a:prstGeom prst="rect">
             <a:avLst/>
@@ -5741,10 +5513,46 @@
           <a:lstStyle/>
           <a:p>
             <a:pPr>
+              <a:defRPr sz="1400" b="1">
+                <a:solidFill>
+                  <a:srgbClr val="111111"/>
+                </a:solidFill>
+                <a:latin typeface="Times New Roman"/>
+              </a:defRPr>
+            </a:pPr>
+            <a:r>
+              <a:t>Real-Time Data Feed</a:t>
+            </a:r>
+          </a:p>
+        </p:txBody>
+      </p:sp>
+      <p:sp>
+        <p:nvSpPr>
+          <p:cNvPr id="9" name="TextBox 8"/>
+          <p:cNvSpPr txBox="1"/>
+          <p:nvPr/>
+        </p:nvSpPr>
+        <p:spPr>
+          <a:xfrm>
+            <a:off x="868680" y="2468880"/>
+            <a:ext cx="2249424" cy="3429000"/>
+          </a:xfrm>
+          <a:prstGeom prst="rect">
+            <a:avLst/>
+          </a:prstGeom>
+          <a:noFill/>
+        </p:spPr>
+        <p:txBody>
+          <a:bodyPr wrap="square">
+            <a:spAutoFit/>
+          </a:bodyPr>
+          <a:lstStyle/>
+          <a:p>
+            <a:pPr>
               <a:spcAft>
-                <a:spcPts val="1200"/>
+                <a:spcPts val="1000"/>
               </a:spcAft>
-              <a:defRPr sz="1500">
+              <a:defRPr sz="1250">
                 <a:solidFill>
                   <a:srgbClr val="222222"/>
                 </a:solidFill>
@@ -5752,15 +5560,15 @@
               </a:defRPr>
             </a:pPr>
             <a:r>
-              <a:t>•  L1-Regularized Portfolio Optimization: min_w { 0.5 w^T Σ w - λ_1 μ^T w + λ_2 ||w||_1 - λ_3 ESG^T w } subject to 1^T w = 1, w_i &gt;= 0.</a:t>
+              <a:t>• Live National Stock Exchange (NSE) data streaming via yfinance.</a:t>
             </a:r>
           </a:p>
           <a:p>
             <a:pPr>
               <a:spcAft>
-                <a:spcPts val="1200"/>
+                <a:spcPts val="1000"/>
               </a:spcAft>
-              <a:defRPr sz="1500">
+              <a:defRPr sz="1250">
                 <a:solidFill>
                   <a:srgbClr val="222222"/>
                 </a:solidFill>
@@ -5768,15 +5576,15 @@
               </a:defRPr>
             </a:pPr>
             <a:r>
-              <a:t>•  KKT Optimality &amp; Sparsity: The non-differentiable L1 vertex drives non-essential weights to exact zero, concentrating capital into 4 blue-chip leaders.</a:t>
+              <a:t>• Tracks 25 blue-chip leaders across Banking, IT, Energy, FMCG &amp; Auto.</a:t>
             </a:r>
           </a:p>
           <a:p>
             <a:pPr>
               <a:spcAft>
-                <a:spcPts val="1200"/>
+                <a:spcPts val="1000"/>
               </a:spcAft>
-              <a:defRPr sz="1500">
+              <a:defRPr sz="1250">
                 <a:solidFill>
                   <a:srgbClr val="222222"/>
                 </a:solidFill>
@@ -5784,15 +5592,155 @@
               </a:defRPr>
             </a:pPr>
             <a:r>
-              <a:t>•  3-State Gaussian Hidden Markov Model: Calibrates transition matrix A and emission distributions N(μ_k, σ_k^2) via Baum-Welch EM; decodes via Viterbi.</a:t>
-            </a:r>
-          </a:p>
+              <a:t>• Checks market open/closed hours automatically.</a:t>
+            </a:r>
+          </a:p>
+        </p:txBody>
+      </p:sp>
+      <p:sp>
+        <p:nvSpPr>
+          <p:cNvPr id="10" name="Rounded Rectangle 9"/>
+          <p:cNvSpPr/>
+          <p:nvPr/>
+        </p:nvSpPr>
+        <p:spPr>
+          <a:xfrm>
+            <a:off x="3456432" y="1371600"/>
+            <a:ext cx="2523744" cy="4663440"/>
+          </a:xfrm>
+          <a:prstGeom prst="roundRect">
+            <a:avLst/>
+          </a:prstGeom>
+          <a:solidFill>
+            <a:srgbClr val="ECFDF5"/>
+          </a:solidFill>
+          <a:ln w="25400">
+            <a:solidFill>
+              <a:srgbClr val="10B981"/>
+            </a:solidFill>
+          </a:ln>
+        </p:spPr>
+        <p:style>
+          <a:lnRef idx="1">
+            <a:schemeClr val="accent1"/>
+          </a:lnRef>
+          <a:fillRef idx="3">
+            <a:schemeClr val="accent1"/>
+          </a:fillRef>
+          <a:effectRef idx="2">
+            <a:schemeClr val="accent1"/>
+          </a:effectRef>
+          <a:fontRef idx="minor">
+            <a:schemeClr val="lt1"/>
+          </a:fontRef>
+        </p:style>
+        <p:txBody>
+          <a:bodyPr rtlCol="0" anchor="ctr"/>
+          <a:lstStyle/>
+          <a:p>
+            <a:pPr algn="ctr"/>
+          </a:p>
+        </p:txBody>
+      </p:sp>
+      <p:sp>
+        <p:nvSpPr>
+          <p:cNvPr id="11" name="TextBox 10"/>
+          <p:cNvSpPr txBox="1"/>
+          <p:nvPr/>
+        </p:nvSpPr>
+        <p:spPr>
+          <a:xfrm>
+            <a:off x="3593592" y="1508760"/>
+            <a:ext cx="2249424" cy="365760"/>
+          </a:xfrm>
+          <a:prstGeom prst="rect">
+            <a:avLst/>
+          </a:prstGeom>
+          <a:noFill/>
+        </p:spPr>
+        <p:txBody>
+          <a:bodyPr wrap="none">
+            <a:spAutoFit/>
+          </a:bodyPr>
+          <a:lstStyle/>
+          <a:p>
+            <a:pPr>
+              <a:defRPr sz="1200" b="1">
+                <a:solidFill>
+                  <a:srgbClr val="10B981"/>
+                </a:solidFill>
+                <a:latin typeface="Times New Roman"/>
+              </a:defRPr>
+            </a:pPr>
+            <a:r>
+              <a:t>STEP 2: FRACTIONAL ENGINE</a:t>
+            </a:r>
+          </a:p>
+        </p:txBody>
+      </p:sp>
+      <p:sp>
+        <p:nvSpPr>
+          <p:cNvPr id="12" name="TextBox 11"/>
+          <p:cNvSpPr txBox="1"/>
+          <p:nvPr/>
+        </p:nvSpPr>
+        <p:spPr>
+          <a:xfrm>
+            <a:off x="3593592" y="1874520"/>
+            <a:ext cx="2249424" cy="548640"/>
+          </a:xfrm>
+          <a:prstGeom prst="rect">
+            <a:avLst/>
+          </a:prstGeom>
+          <a:noFill/>
+        </p:spPr>
+        <p:txBody>
+          <a:bodyPr wrap="square">
+            <a:spAutoFit/>
+          </a:bodyPr>
+          <a:lstStyle/>
+          <a:p>
+            <a:pPr>
+              <a:defRPr sz="1400" b="1">
+                <a:solidFill>
+                  <a:srgbClr val="111111"/>
+                </a:solidFill>
+                <a:latin typeface="Times New Roman"/>
+              </a:defRPr>
+            </a:pPr>
+            <a:r>
+              <a:t>Zero-Waste Micro-Investing</a:t>
+            </a:r>
+          </a:p>
+        </p:txBody>
+      </p:sp>
+      <p:sp>
+        <p:nvSpPr>
+          <p:cNvPr id="13" name="TextBox 12"/>
+          <p:cNvSpPr txBox="1"/>
+          <p:nvPr/>
+        </p:nvSpPr>
+        <p:spPr>
+          <a:xfrm>
+            <a:off x="3593592" y="2468880"/>
+            <a:ext cx="2249424" cy="3429000"/>
+          </a:xfrm>
+          <a:prstGeom prst="rect">
+            <a:avLst/>
+          </a:prstGeom>
+          <a:noFill/>
+        </p:spPr>
+        <p:txBody>
+          <a:bodyPr wrap="square">
+            <a:spAutoFit/>
+          </a:bodyPr>
+          <a:lstStyle/>
           <a:p>
             <a:pPr>
               <a:spcAft>
-                <a:spcPts val="1200"/>
+                <a:spcPts val="1000"/>
               </a:spcAft>
-              <a:defRPr sz="1500">
+              <a:defRPr sz="1250">
                 <a:solidFill>
                   <a:srgbClr val="222222"/>
                 </a:solidFill>
@@ -5800,15 +5748,15 @@
               </a:defRPr>
             </a:pPr>
             <a:r>
-              <a:t>•  3D Tensor Tucker Decomposition (HoSVD): Decomposes tensor X ≈ G ×_1 U_1 ×_2 U_2 ×_3 U_3 across assets, time, and macroeconomic factor modes.</a:t>
+              <a:t>• User enters any budget (e.g. ₹100, ₹500, or ₹5,000).</a:t>
             </a:r>
           </a:p>
           <a:p>
             <a:pPr>
               <a:spcAft>
-                <a:spcPts val="1200"/>
+                <a:spcPts val="1000"/>
               </a:spcAft>
-              <a:defRPr sz="1500">
+              <a:defRPr sz="1250">
                 <a:solidFill>
                   <a:srgbClr val="222222"/>
                 </a:solidFill>
@@ -5816,15 +5764,15 @@
               </a:defRPr>
             </a:pPr>
             <a:r>
-              <a:t>•  Qiskit Quantum Option Pricing (QAE): Grover operator Q = -A S_0 A^† S_χ rotates statevectors to price call options with quadratic speedup O(1/ε).</a:t>
+              <a:t>• Calculates fractional shares down to 0.0001 precision.</a:t>
             </a:r>
           </a:p>
           <a:p>
             <a:pPr>
               <a:spcAft>
-                <a:spcPts val="1200"/>
+                <a:spcPts val="1000"/>
               </a:spcAft>
-              <a:defRPr sz="1500">
+              <a:defRPr sz="1250">
                 <a:solidFill>
                   <a:srgbClr val="222222"/>
                 </a:solidFill>
@@ -5832,7 +5780,383 @@
               </a:defRPr>
             </a:pPr>
             <a:r>
-              <a:t>•  4-Tier Production Pipeline: Real-time NSE ingestion (yfinance) → Quant computation (CVXOPT) → Payments (NPCI/UPI) → Reactive Streamlit UI.</a:t>
+              <a:t>• Ensures 100% of money is invested with zero cash drag.</a:t>
+            </a:r>
+          </a:p>
+        </p:txBody>
+      </p:sp>
+      <p:sp>
+        <p:nvSpPr>
+          <p:cNvPr id="14" name="Rounded Rectangle 13"/>
+          <p:cNvSpPr/>
+          <p:nvPr/>
+        </p:nvSpPr>
+        <p:spPr>
+          <a:xfrm>
+            <a:off x="6181344" y="1371600"/>
+            <a:ext cx="2523744" cy="4663440"/>
+          </a:xfrm>
+          <a:prstGeom prst="roundRect">
+            <a:avLst/>
+          </a:prstGeom>
+          <a:solidFill>
+            <a:srgbClr val="FEF2F2"/>
+          </a:solidFill>
+          <a:ln w="25400">
+            <a:solidFill>
+              <a:srgbClr val="E11D48"/>
+            </a:solidFill>
+          </a:ln>
+        </p:spPr>
+        <p:style>
+          <a:lnRef idx="1">
+            <a:schemeClr val="accent1"/>
+          </a:lnRef>
+          <a:fillRef idx="3">
+            <a:schemeClr val="accent1"/>
+          </a:fillRef>
+          <a:effectRef idx="2">
+            <a:schemeClr val="accent1"/>
+          </a:effectRef>
+          <a:fontRef idx="minor">
+            <a:schemeClr val="lt1"/>
+          </a:fontRef>
+        </p:style>
+        <p:txBody>
+          <a:bodyPr rtlCol="0" anchor="ctr"/>
+          <a:lstStyle/>
+          <a:p>
+            <a:pPr algn="ctr"/>
+          </a:p>
+        </p:txBody>
+      </p:sp>
+      <p:sp>
+        <p:nvSpPr>
+          <p:cNvPr id="15" name="TextBox 14"/>
+          <p:cNvSpPr txBox="1"/>
+          <p:nvPr/>
+        </p:nvSpPr>
+        <p:spPr>
+          <a:xfrm>
+            <a:off x="6318504" y="1508760"/>
+            <a:ext cx="2249424" cy="365760"/>
+          </a:xfrm>
+          <a:prstGeom prst="rect">
+            <a:avLst/>
+          </a:prstGeom>
+          <a:noFill/>
+        </p:spPr>
+        <p:txBody>
+          <a:bodyPr wrap="none">
+            <a:spAutoFit/>
+          </a:bodyPr>
+          <a:lstStyle/>
+          <a:p>
+            <a:pPr>
+              <a:defRPr sz="1200" b="1">
+                <a:solidFill>
+                  <a:srgbClr val="E11D48"/>
+                </a:solidFill>
+                <a:latin typeface="Times New Roman"/>
+              </a:defRPr>
+            </a:pPr>
+            <a:r>
+              <a:t>STEP 3: QUANT CORE</a:t>
+            </a:r>
+          </a:p>
+        </p:txBody>
+      </p:sp>
+      <p:sp>
+        <p:nvSpPr>
+          <p:cNvPr id="16" name="TextBox 15"/>
+          <p:cNvSpPr txBox="1"/>
+          <p:nvPr/>
+        </p:nvSpPr>
+        <p:spPr>
+          <a:xfrm>
+            <a:off x="6318504" y="1874520"/>
+            <a:ext cx="2249424" cy="548640"/>
+          </a:xfrm>
+          <a:prstGeom prst="rect">
+            <a:avLst/>
+          </a:prstGeom>
+          <a:noFill/>
+        </p:spPr>
+        <p:txBody>
+          <a:bodyPr wrap="square">
+            <a:spAutoFit/>
+          </a:bodyPr>
+          <a:lstStyle/>
+          <a:p>
+            <a:pPr>
+              <a:defRPr sz="1400" b="1">
+                <a:solidFill>
+                  <a:srgbClr val="111111"/>
+                </a:solidFill>
+                <a:latin typeface="Times New Roman"/>
+              </a:defRPr>
+            </a:pPr>
+            <a:r>
+              <a:t>Smart Math &amp; Risk Control</a:t>
+            </a:r>
+          </a:p>
+        </p:txBody>
+      </p:sp>
+      <p:sp>
+        <p:nvSpPr>
+          <p:cNvPr id="17" name="TextBox 16"/>
+          <p:cNvSpPr txBox="1"/>
+          <p:nvPr/>
+        </p:nvSpPr>
+        <p:spPr>
+          <a:xfrm>
+            <a:off x="6318504" y="2468880"/>
+            <a:ext cx="2249424" cy="3429000"/>
+          </a:xfrm>
+          <a:prstGeom prst="rect">
+            <a:avLst/>
+          </a:prstGeom>
+          <a:noFill/>
+        </p:spPr>
+        <p:txBody>
+          <a:bodyPr wrap="square">
+            <a:spAutoFit/>
+          </a:bodyPr>
+          <a:lstStyle/>
+          <a:p>
+            <a:pPr>
+              <a:spcAft>
+                <a:spcPts val="1000"/>
+              </a:spcAft>
+              <a:defRPr sz="1250">
+                <a:solidFill>
+                  <a:srgbClr val="222222"/>
+                </a:solidFill>
+                <a:latin typeface="Times New Roman"/>
+              </a:defRPr>
+            </a:pPr>
+            <a:r>
+              <a:t>• L1 Sparse Optimization: Picks top 4 stocks, cutting fees by 43.8%.</a:t>
+            </a:r>
+          </a:p>
+          <a:p>
+            <a:pPr>
+              <a:spcAft>
+                <a:spcPts val="1000"/>
+              </a:spcAft>
+              <a:defRPr sz="1250">
+                <a:solidFill>
+                  <a:srgbClr val="222222"/>
+                </a:solidFill>
+                <a:latin typeface="Times New Roman"/>
+              </a:defRPr>
+            </a:pPr>
+            <a:r>
+              <a:t>• Gaussian HMM: Detects Bull vs Bear market cycles.</a:t>
+            </a:r>
+          </a:p>
+          <a:p>
+            <a:pPr>
+              <a:spcAft>
+                <a:spcPts val="1000"/>
+              </a:spcAft>
+              <a:defRPr sz="1250">
+                <a:solidFill>
+                  <a:srgbClr val="222222"/>
+                </a:solidFill>
+                <a:latin typeface="Times New Roman"/>
+              </a:defRPr>
+            </a:pPr>
+            <a:r>
+              <a:t>• Qiskit Quantum QAE: Fast option pricing with quadratic speedup.</a:t>
+            </a:r>
+          </a:p>
+        </p:txBody>
+      </p:sp>
+      <p:sp>
+        <p:nvSpPr>
+          <p:cNvPr id="18" name="Rounded Rectangle 17"/>
+          <p:cNvSpPr/>
+          <p:nvPr/>
+        </p:nvSpPr>
+        <p:spPr>
+          <a:xfrm>
+            <a:off x="8906256" y="1371600"/>
+            <a:ext cx="2523744" cy="4663440"/>
+          </a:xfrm>
+          <a:prstGeom prst="roundRect">
+            <a:avLst/>
+          </a:prstGeom>
+          <a:solidFill>
+            <a:srgbClr val="FEF9C3"/>
+          </a:solidFill>
+          <a:ln w="25400">
+            <a:solidFill>
+              <a:srgbClr val="CA8A04"/>
+            </a:solidFill>
+          </a:ln>
+        </p:spPr>
+        <p:style>
+          <a:lnRef idx="1">
+            <a:schemeClr val="accent1"/>
+          </a:lnRef>
+          <a:fillRef idx="3">
+            <a:schemeClr val="accent1"/>
+          </a:fillRef>
+          <a:effectRef idx="2">
+            <a:schemeClr val="accent1"/>
+          </a:effectRef>
+          <a:fontRef idx="minor">
+            <a:schemeClr val="lt1"/>
+          </a:fontRef>
+        </p:style>
+        <p:txBody>
+          <a:bodyPr rtlCol="0" anchor="ctr"/>
+          <a:lstStyle/>
+          <a:p>
+            <a:pPr algn="ctr"/>
+          </a:p>
+        </p:txBody>
+      </p:sp>
+      <p:sp>
+        <p:nvSpPr>
+          <p:cNvPr id="19" name="TextBox 18"/>
+          <p:cNvSpPr txBox="1"/>
+          <p:nvPr/>
+        </p:nvSpPr>
+        <p:spPr>
+          <a:xfrm>
+            <a:off x="9043416" y="1508760"/>
+            <a:ext cx="2249424" cy="365760"/>
+          </a:xfrm>
+          <a:prstGeom prst="rect">
+            <a:avLst/>
+          </a:prstGeom>
+          <a:noFill/>
+        </p:spPr>
+        <p:txBody>
+          <a:bodyPr wrap="none">
+            <a:spAutoFit/>
+          </a:bodyPr>
+          <a:lstStyle/>
+          <a:p>
+            <a:pPr>
+              <a:defRPr sz="1200" b="1">
+                <a:solidFill>
+                  <a:srgbClr val="CA8A04"/>
+                </a:solidFill>
+                <a:latin typeface="Times New Roman"/>
+              </a:defRPr>
+            </a:pPr>
+            <a:r>
+              <a:t>STEP 4: 1-CLICK EXECUTION</a:t>
+            </a:r>
+          </a:p>
+        </p:txBody>
+      </p:sp>
+      <p:sp>
+        <p:nvSpPr>
+          <p:cNvPr id="20" name="TextBox 19"/>
+          <p:cNvSpPr txBox="1"/>
+          <p:nvPr/>
+        </p:nvSpPr>
+        <p:spPr>
+          <a:xfrm>
+            <a:off x="9043416" y="1874520"/>
+            <a:ext cx="2249424" cy="548640"/>
+          </a:xfrm>
+          <a:prstGeom prst="rect">
+            <a:avLst/>
+          </a:prstGeom>
+          <a:noFill/>
+        </p:spPr>
+        <p:txBody>
+          <a:bodyPr wrap="square">
+            <a:spAutoFit/>
+          </a:bodyPr>
+          <a:lstStyle/>
+          <a:p>
+            <a:pPr>
+              <a:defRPr sz="1400" b="1">
+                <a:solidFill>
+                  <a:srgbClr val="111111"/>
+                </a:solidFill>
+                <a:latin typeface="Times New Roman"/>
+              </a:defRPr>
+            </a:pPr>
+            <a:r>
+              <a:t>UPI &amp; Live Portfolio Ledger</a:t>
+            </a:r>
+          </a:p>
+        </p:txBody>
+      </p:sp>
+      <p:sp>
+        <p:nvSpPr>
+          <p:cNvPr id="21" name="TextBox 20"/>
+          <p:cNvSpPr txBox="1"/>
+          <p:nvPr/>
+        </p:nvSpPr>
+        <p:spPr>
+          <a:xfrm>
+            <a:off x="9043416" y="2468880"/>
+            <a:ext cx="2249424" cy="3429000"/>
+          </a:xfrm>
+          <a:prstGeom prst="rect">
+            <a:avLst/>
+          </a:prstGeom>
+          <a:noFill/>
+        </p:spPr>
+        <p:txBody>
+          <a:bodyPr wrap="square">
+            <a:spAutoFit/>
+          </a:bodyPr>
+          <a:lstStyle/>
+          <a:p>
+            <a:pPr>
+              <a:spcAft>
+                <a:spcPts val="1000"/>
+              </a:spcAft>
+              <a:defRPr sz="1250">
+                <a:solidFill>
+                  <a:srgbClr val="222222"/>
+                </a:solidFill>
+                <a:latin typeface="Times New Roman"/>
+              </a:defRPr>
+            </a:pPr>
+            <a:r>
+              <a:t>• 1-Click UPI Payment launch (Google Pay / PhonePe / Paytm).</a:t>
+            </a:r>
+          </a:p>
+          <a:p>
+            <a:pPr>
+              <a:spcAft>
+                <a:spcPts val="1000"/>
+              </a:spcAft>
+              <a:defRPr sz="1250">
+                <a:solidFill>
+                  <a:srgbClr val="222222"/>
+                </a:solidFill>
+                <a:latin typeface="Times New Roman"/>
+              </a:defRPr>
+            </a:pPr>
+            <a:r>
+              <a:t>• Live Portfolio tracking: Shares, value, and real-time profit/loss.</a:t>
+            </a:r>
+          </a:p>
+          <a:p>
+            <a:pPr>
+              <a:spcAft>
+                <a:spcPts val="1000"/>
+              </a:spcAft>
+              <a:defRPr sz="1250">
+                <a:solidFill>
+                  <a:srgbClr val="222222"/>
+                </a:solidFill>
+                <a:latin typeface="Times New Roman"/>
+              </a:defRPr>
+            </a:pPr>
+            <a:r>
+              <a:t>• Instant sell buttons: Cash returns directly to wallet balance.</a:t>
             </a:r>
           </a:p>
         </p:txBody>
@@ -6018,7 +6342,7 @@
           <a:p>
             <a:pPr>
               <a:spcAft>
-                <a:spcPts val="1200"/>
+                <a:spcPts val="1400"/>
               </a:spcAft>
               <a:defRPr sz="1500">
                 <a:solidFill>
@@ -6028,13 +6352,13 @@
               </a:defRPr>
             </a:pPr>
             <a:r>
-              <a:t>•  Core Programming &amp; Mathematics: Python 3.13, NumPy (vectorized tensor algebra), SciPy (optimization &amp; statistics), Pandas (timeseries).</a:t>
+              <a:t>•  Core Programming: Python 3.13 with NumPy, Pandas, and SciPy for high-speed mathematical computations.</a:t>
             </a:r>
           </a:p>
           <a:p>
             <a:pPr>
               <a:spcAft>
-                <a:spcPts val="1200"/>
+                <a:spcPts val="1400"/>
               </a:spcAft>
               <a:defRPr sz="1500">
                 <a:solidFill>
@@ -6044,13 +6368,13 @@
               </a:defRPr>
             </a:pPr>
             <a:r>
-              <a:t>•  Convex Optimization &amp; Quantum Simulation: CVXOPT (L1 quadratic solver), Qiskit Aer (Quantum Amplitude Estimation &amp; statevector circuit execution).</a:t>
+              <a:t>•  Portfolio Optimization: CVXOPT library to solve L1-Regularized Sparse Markowitz portfolio weights.</a:t>
             </a:r>
           </a:p>
           <a:p>
             <a:pPr>
               <a:spcAft>
-                <a:spcPts val="1200"/>
+                <a:spcPts val="1400"/>
               </a:spcAft>
               <a:defRPr sz="1500">
                 <a:solidFill>
@@ -6060,13 +6384,13 @@
               </a:defRPr>
             </a:pPr>
             <a:r>
-              <a:t>•  Real-Time Market Data: yfinance streaming live National Stock Exchange (.NS) blue-chip quotes with 60-second TTL caching.</a:t>
+              <a:t>•  Quantum Computing Engine: Qiskit by IBM Quantum to build and simulate Quantum Amplitude Estimation circuits.</a:t>
             </a:r>
           </a:p>
           <a:p>
             <a:pPr>
               <a:spcAft>
-                <a:spcPts val="1200"/>
+                <a:spcPts val="1400"/>
               </a:spcAft>
               <a:defRPr sz="1500">
                 <a:solidFill>
@@ -6076,13 +6400,13 @@
               </a:defRPr>
             </a:pPr>
             <a:r>
-              <a:t>•  Frontend UI &amp; Visualizations: Streamlit Community Cloud (reactive fintech dashboard), Plotly (interactive 60-day candlestick &amp; 20-Day SMA charts).</a:t>
+              <a:t>•  Live Stock Market Data: yfinance API streaming real-time prices directly from the National Stock Exchange (NSE).</a:t>
             </a:r>
           </a:p>
           <a:p>
             <a:pPr>
               <a:spcAft>
-                <a:spcPts val="1200"/>
+                <a:spcPts val="1400"/>
               </a:spcAft>
               <a:defRPr sz="1500">
                 <a:solidFill>
@@ -6092,13 +6416,13 @@
               </a:defRPr>
             </a:pPr>
             <a:r>
-              <a:t>•  Banking &amp; Payment Infrastructure: NPCI UPI Intent deep-linking (Google Pay, PhonePe, Paytm), Razorpay Python SDK, RBI Account Aggregator.</a:t>
+              <a:t>•  Interactive Web Dashboard: Streamlit Community Cloud and Plotly for real-time candlestick charts and mobile UI.</a:t>
             </a:r>
           </a:p>
           <a:p>
             <a:pPr>
               <a:spcAft>
-                <a:spcPts val="1200"/>
+                <a:spcPts val="1400"/>
               </a:spcAft>
               <a:defRPr sz="1500">
                 <a:solidFill>
@@ -6108,7 +6432,7 @@
               </a:defRPr>
             </a:pPr>
             <a:r>
-              <a:t>•  DevOps &amp; Version Control: Git, GitHub CI/CD, and 256-bit SSL encrypted secure session management.</a:t>
+              <a:t>•  Payments &amp; Banking Security: NPCI UPI Intent protocol (for GPay/PhonePe/Paytm), Razorpay SDK, and RBI Account Aggregator.</a:t>
             </a:r>
           </a:p>
         </p:txBody>
@@ -6294,7 +6618,7 @@
           <a:p>
             <a:pPr>
               <a:spcAft>
-                <a:spcPts val="1200"/>
+                <a:spcPts val="1400"/>
               </a:spcAft>
               <a:defRPr sz="1500">
                 <a:solidFill>
@@ -6304,13 +6628,13 @@
               </a:defRPr>
             </a:pPr>
             <a:r>
-              <a:t>•  1. Real-Time Market Intelligence: 25 NSE blue-chips streaming live prices, gainers/losers, IST trading hours clock, and AI Quant Health Rankings.</a:t>
+              <a:t>•  1. Real-Time Market Intelligence: Built live tracking for 25 NSE blue-chip stocks with daily gainers/losers and AI Health Rankings.</a:t>
             </a:r>
           </a:p>
           <a:p>
             <a:pPr>
               <a:spcAft>
-                <a:spcPts val="1200"/>
+                <a:spcPts val="1400"/>
               </a:spcAft>
               <a:defRPr sz="1500">
                 <a:solidFill>
@@ -6320,13 +6644,13 @@
               </a:defRPr>
             </a:pPr>
             <a:r>
-              <a:t>•  2. Zero-Knowledge Auto-Pilot Engine: Parameterized fractional share split for any rupee amount (₹100 to ₹10L) with live UPI intent launch.</a:t>
+              <a:t>•  2. Zero-Knowledge Auto-Pilot: Created an automated fractional allocation engine with instant UPI payment deep-links.</a:t>
             </a:r>
           </a:p>
           <a:p>
             <a:pPr>
               <a:spcAft>
-                <a:spcPts val="1200"/>
+                <a:spcPts val="1400"/>
               </a:spcAft>
               <a:defRPr sz="1500">
                 <a:solidFill>
@@ -6336,13 +6660,13 @@
               </a:defRPr>
             </a:pPr>
             <a:r>
-              <a:t>•  3. Live Portfolio Ledger &amp; Liquid Sell: Real-time holdings tracking, live mark-to-market P&amp;L, 50%/100% sell execution, and audit history.</a:t>
+              <a:t>•  3. Live Portfolio &amp; Sell Ledger: Built active holdings management with real-time profit/loss tracking and 1-click sell buttons.</a:t>
             </a:r>
           </a:p>
           <a:p>
             <a:pPr>
               <a:spcAft>
-                <a:spcPts val="1200"/>
+                <a:spcPts val="1400"/>
               </a:spcAft>
               <a:defRPr sz="1500">
                 <a:solidFill>
@@ -6352,13 +6676,13 @@
               </a:defRPr>
             </a:pPr>
             <a:r>
-              <a:t>•  4. Quant Pro Mathematical Laboratory: MDP Q-Learning RL slicer (3.1 bps slippage), Gaussian HMM regime chart, 3D Tensor HoSVD, and CVXOPT frontier.</a:t>
+              <a:t>•  4. Quant Pro Laboratory: Implemented the MDP Trade Slicer, Gaussian HMM Regimes, 3D Tensor Tucker Loadings, and Quantum QAE.</a:t>
             </a:r>
           </a:p>
           <a:p>
             <a:pPr>
               <a:spcAft>
-                <a:spcPts val="1200"/>
+                <a:spcPts val="1400"/>
               </a:spcAft>
               <a:defRPr sz="1500">
                 <a:solidFill>
@@ -6368,13 +6692,13 @@
               </a:defRPr>
             </a:pPr>
             <a:r>
-              <a:t>•  5. Regulatory Onboarding &amp; Banking: SEBI/RBI risk disclosure acceptance screen, NPCI mobile OTP simulation, and custom bank balance editor.</a:t>
+              <a:t>•  5. Investor Safety &amp; Bank Linking: Added mandatory SEBI/RBI risk disclosure acceptance and NPCI mobile OTP verification.</a:t>
             </a:r>
           </a:p>
           <a:p>
             <a:pPr>
               <a:spcAft>
-                <a:spcPts val="1200"/>
+                <a:spcPts val="1400"/>
               </a:spcAft>
               <a:defRPr sz="1500">
                 <a:solidFill>
@@ -6384,7 +6708,7 @@
               </a:defRPr>
             </a:pPr>
             <a:r>
-              <a:t>•  Production Status: 100% verified, live on Streamlit Cloud (https://sparsioq-platform.streamlit.app) without any simulated or mocked prices.</a:t>
+              <a:t>•  Cloud Deployment: The platform is fully live and publicly accessible on Streamlit Cloud (https://sparsioq-platform.streamlit.app).</a:t>
             </a:r>
           </a:p>
         </p:txBody>
@@ -6565,7 +6889,7 @@
           </a:solidFill>
           <a:ln w="12700">
             <a:solidFill>
-              <a:srgbClr val="C8C8C8"/>
+              <a:srgbClr val="D2D7E1"/>
             </a:solidFill>
           </a:ln>
         </p:spPr>
@@ -6706,7 +7030,7 @@
           </a:solidFill>
           <a:ln w="12700">
             <a:solidFill>
-              <a:srgbClr val="C8C8C8"/>
+              <a:srgbClr val="D2D7E1"/>
             </a:solidFill>
           </a:ln>
         </p:spPr>
@@ -6847,7 +7171,7 @@
           </a:solidFill>
           <a:ln w="12700">
             <a:solidFill>
-              <a:srgbClr val="C8C8C8"/>
+              <a:srgbClr val="D2D7E1"/>
             </a:solidFill>
           </a:ln>
         </p:spPr>
@@ -6988,7 +7312,7 @@
           </a:solidFill>
           <a:ln w="12700">
             <a:solidFill>
-              <a:srgbClr val="C8C8C8"/>
+              <a:srgbClr val="D2D7E1"/>
             </a:solidFill>
           </a:ln>
         </p:spPr>
@@ -7129,7 +7453,7 @@
           </a:solidFill>
           <a:ln w="12700">
             <a:solidFill>
-              <a:srgbClr val="C8C8C8"/>
+              <a:srgbClr val="D2D7E1"/>
             </a:solidFill>
           </a:ln>
         </p:spPr>
@@ -7270,7 +7594,7 @@
           </a:solidFill>
           <a:ln w="12700">
             <a:solidFill>
-              <a:srgbClr val="C8C8C8"/>
+              <a:srgbClr val="D2D7E1"/>
             </a:solidFill>
           </a:ln>
         </p:spPr>
@@ -7411,7 +7735,7 @@
           </a:solidFill>
           <a:ln w="12700">
             <a:solidFill>
-              <a:srgbClr val="C8C8C8"/>
+              <a:srgbClr val="D2D7E1"/>
             </a:solidFill>
           </a:ln>
         </p:spPr>
@@ -7552,7 +7876,7 @@
           </a:solidFill>
           <a:ln w="12700">
             <a:solidFill>
-              <a:srgbClr val="C8C8C8"/>
+              <a:srgbClr val="D2D7E1"/>
             </a:solidFill>
           </a:ln>
         </p:spPr>
@@ -7693,7 +8017,7 @@
           </a:solidFill>
           <a:ln w="12700">
             <a:solidFill>
-              <a:srgbClr val="C8C8C8"/>
+              <a:srgbClr val="D2D7E1"/>
             </a:solidFill>
           </a:ln>
         </p:spPr>
@@ -7834,7 +8158,7 @@
           </a:solidFill>
           <a:ln w="12700">
             <a:solidFill>
-              <a:srgbClr val="C8C8C8"/>
+              <a:srgbClr val="D2D7E1"/>
             </a:solidFill>
           </a:ln>
         </p:spPr>

</xml_diff>